<commit_message>
feat(rbac): consolidate product roles
</commit_message>
<xml_diff>
--- a/docs/T.A.I.S-项目介绍.pptx
+++ b/docs/T.A.I.S-项目介绍.pptx
@@ -3468,7 +3468,6 @@
         </p:spPr>
         <p:txBody>
           <a:bodyPr wrap="square" lIns="0" tIns="0" rIns="0" bIns="0" rtlCol="0" anchor="ctr"/>
-          <a:normAutofit/>
           <a:lstStyle/>
           <a:p>
             <a:pPr indent="0" marL="0">
@@ -4236,7 +4235,6 @@
         </p:spPr>
         <p:txBody>
           <a:bodyPr wrap="square" lIns="0" tIns="0" rIns="0" bIns="0" rtlCol="0" anchor="ctr"/>
-          <a:normAutofit/>
           <a:lstStyle/>
           <a:p>
             <a:pPr indent="0" marL="0">
@@ -4455,7 +4453,7 @@
       </p:sp>
       <p:pic>
         <p:nvPicPr>
-          <p:cNvPr id="9" name="Image 0" descr="/home/shenss/python/Agno-AIOS/docs/assets/tais-architecture.png"/>
+          <p:cNvPr id="9" name="Image 0" descr="/home/shenss/python/Agno-AIOS/docs/assets/tais-architecture.png">    </p:cNvPr>
           <p:cNvPicPr>
             <a:picLocks noChangeAspect="1"/>
           </p:cNvPicPr>
@@ -4948,7 +4946,6 @@
         </p:spPr>
         <p:txBody>
           <a:bodyPr wrap="square" lIns="0" tIns="0" rIns="0" bIns="0" rtlCol="0" anchor="ctr"/>
-          <a:normAutofit/>
           <a:lstStyle/>
           <a:p>
             <a:pPr indent="0" marL="0">
@@ -6340,7 +6337,6 @@
         </p:spPr>
         <p:txBody>
           <a:bodyPr wrap="square" lIns="0" tIns="0" rIns="0" bIns="0" rtlCol="0" anchor="ctr"/>
-          <a:normAutofit/>
           <a:lstStyle/>
           <a:p>
             <a:pPr indent="0" marL="0">
@@ -6586,7 +6582,7 @@
       </p:sp>
       <p:pic>
         <p:nvPicPr>
-          <p:cNvPr id="10" name="Image 0" descr="preencoded.png"/>
+          <p:cNvPr id="10" name="Image 0" descr="preencoded.png">    </p:cNvPr>
           <p:cNvPicPr>
             <a:picLocks noChangeAspect="1"/>
           </p:cNvPicPr>
@@ -6788,7 +6784,7 @@
       </p:sp>
       <p:pic>
         <p:nvPicPr>
-          <p:cNvPr id="14" name="Image 1" descr="preencoded.png"/>
+          <p:cNvPr id="14" name="Image 1" descr="preencoded.png">    </p:cNvPr>
           <p:cNvPicPr>
             <a:picLocks noChangeAspect="1"/>
           </p:cNvPicPr>
@@ -7012,7 +7008,6 @@
         </p:spPr>
         <p:txBody>
           <a:bodyPr wrap="square" lIns="0" tIns="0" rIns="0" bIns="0" rtlCol="0" anchor="ctr"/>
-          <a:normAutofit/>
           <a:lstStyle/>
           <a:p>
             <a:pPr indent="0" marL="0">
@@ -7258,7 +7253,7 @@
       </p:sp>
       <p:pic>
         <p:nvPicPr>
-          <p:cNvPr id="10" name="Image 0" descr="preencoded.png"/>
+          <p:cNvPr id="10" name="Image 0" descr="preencoded.png">    </p:cNvPr>
           <p:cNvPicPr>
             <a:picLocks noChangeAspect="1"/>
           </p:cNvPicPr>
@@ -7387,7 +7382,7 @@
       </p:sp>
       <p:pic>
         <p:nvPicPr>
-          <p:cNvPr id="14" name="Image 1" descr="preencoded.png"/>
+          <p:cNvPr id="14" name="Image 1" descr="preencoded.png">    </p:cNvPr>
           <p:cNvPicPr>
             <a:picLocks noChangeAspect="1"/>
           </p:cNvPicPr>
@@ -7516,7 +7511,7 @@
       </p:sp>
       <p:pic>
         <p:nvPicPr>
-          <p:cNvPr id="18" name="Image 2" descr="preencoded.png"/>
+          <p:cNvPr id="18" name="Image 2" descr="preencoded.png">    </p:cNvPr>
           <p:cNvPicPr>
             <a:picLocks noChangeAspect="1"/>
           </p:cNvPicPr>
@@ -7645,7 +7640,7 @@
       </p:sp>
       <p:pic>
         <p:nvPicPr>
-          <p:cNvPr id="22" name="Image 3" descr="preencoded.png"/>
+          <p:cNvPr id="22" name="Image 3" descr="preencoded.png">    </p:cNvPr>
           <p:cNvPicPr>
             <a:picLocks noChangeAspect="1"/>
           </p:cNvPicPr>
@@ -7796,7 +7791,6 @@
         </p:spPr>
         <p:txBody>
           <a:bodyPr wrap="square" lIns="0" tIns="0" rIns="0" bIns="0" rtlCol="0" anchor="ctr"/>
-          <a:normAutofit/>
           <a:lstStyle/>
           <a:p>
             <a:pPr indent="0" marL="0">
@@ -8042,7 +8036,7 @@
       </p:sp>
       <p:pic>
         <p:nvPicPr>
-          <p:cNvPr id="10" name="Image 0" descr="preencoded.png"/>
+          <p:cNvPr id="10" name="Image 0" descr="preencoded.png">    </p:cNvPr>
           <p:cNvPicPr>
             <a:picLocks noChangeAspect="1"/>
           </p:cNvPicPr>
@@ -8136,7 +8130,7 @@
                 <a:ea typeface="Arial" pitchFamily="34" charset="-122"/>
                 <a:cs typeface="Arial" pitchFamily="34" charset="-120"/>
               </a:rPr>
-              <a:t>admin / analyst / author / approver / auditor / guest；JWT scopes 驱动导航与写操作。</a:t>
+              <a:t>admin / user；JWT scopes 驱动导航与写操作。</a:t>
             </a:r>
             <a:endParaRPr lang="en-US" sz="1300" dirty="0"/>
           </a:p>
@@ -8171,7 +8165,7 @@
       </p:sp>
       <p:pic>
         <p:nvPicPr>
-          <p:cNvPr id="14" name="Image 1" descr="preencoded.png"/>
+          <p:cNvPr id="14" name="Image 1" descr="preencoded.png">    </p:cNvPr>
           <p:cNvPicPr>
             <a:picLocks noChangeAspect="1"/>
           </p:cNvPicPr>
@@ -8300,7 +8294,7 @@
       </p:sp>
       <p:pic>
         <p:nvPicPr>
-          <p:cNvPr id="18" name="Image 2" descr="preencoded.png"/>
+          <p:cNvPr id="18" name="Image 2" descr="preencoded.png">    </p:cNvPr>
           <p:cNvPicPr>
             <a:picLocks noChangeAspect="1"/>
           </p:cNvPicPr>
@@ -8429,7 +8423,7 @@
       </p:sp>
       <p:pic>
         <p:nvPicPr>
-          <p:cNvPr id="22" name="Image 3" descr="preencoded.png"/>
+          <p:cNvPr id="22" name="Image 3" descr="preencoded.png">    </p:cNvPr>
           <p:cNvPicPr>
             <a:picLocks noChangeAspect="1"/>
           </p:cNvPicPr>
@@ -8558,7 +8552,7 @@
       </p:sp>
       <p:pic>
         <p:nvPicPr>
-          <p:cNvPr id="26" name="Image 4" descr="preencoded.png"/>
+          <p:cNvPr id="26" name="Image 4" descr="preencoded.png">    </p:cNvPr>
           <p:cNvPicPr>
             <a:picLocks noChangeAspect="1"/>
           </p:cNvPicPr>
@@ -8687,7 +8681,7 @@
       </p:sp>
       <p:pic>
         <p:nvPicPr>
-          <p:cNvPr id="30" name="Image 5" descr="preencoded.png"/>
+          <p:cNvPr id="30" name="Image 5" descr="preencoded.png">    </p:cNvPr>
           <p:cNvPicPr>
             <a:picLocks noChangeAspect="1"/>
           </p:cNvPicPr>
@@ -8838,7 +8832,6 @@
         </p:spPr>
         <p:txBody>
           <a:bodyPr wrap="square" lIns="0" tIns="0" rIns="0" bIns="0" rtlCol="0" anchor="ctr"/>
-          <a:normAutofit/>
           <a:lstStyle/>
           <a:p>
             <a:pPr indent="0" marL="0">

</xml_diff>